<commit_message>
Add confirmed Static 1 mesh parameters and mesh-halving methodology explanation
</commit_message>
<xml_diff>
--- a/Assessment3_Presentation.pptx
+++ b/Assessment3_Presentation.pptx
@@ -3761,7 +3761,7 @@
         <p:spPr>
           <a:xfrm>
             <a:off x="411480" y="1737360"/>
-            <a:ext cx="5349240" cy="1828800"/>
+            <a:ext cx="5349240" cy="3017520"/>
           </a:xfrm>
           <a:prstGeom prst="rect">
             <a:avLst/>
@@ -3776,7 +3776,7 @@
           <a:p>
             <a:pPr>
               <a:spcBef>
-                <a:spcPts val="600"/>
+                <a:spcPts val="1000"/>
               </a:spcBef>
             </a:pPr>
             <a:r>
@@ -4515,7 +4515,7 @@
         <p:spPr>
           <a:xfrm>
             <a:off x="411480" y="1737360"/>
-            <a:ext cx="5349240" cy="1828800"/>
+            <a:ext cx="5349240" cy="3017520"/>
           </a:xfrm>
           <a:prstGeom prst="rect">
             <a:avLst/>
@@ -4530,7 +4530,7 @@
           <a:p>
             <a:pPr>
               <a:spcBef>
-                <a:spcPts val="600"/>
+                <a:spcPts val="1000"/>
               </a:spcBef>
             </a:pPr>
             <a:r>
@@ -7642,7 +7642,7 @@
                   <a:srgbClr val="FFFFFF"/>
                 </a:solidFill>
               </a:rPr>
-              <a:t>Instructions to Complete This Table</a:t>
+              <a:t>Methodology: Why Mesh Size is Halved Each Iteration</a:t>
             </a:r>
           </a:p>
         </p:txBody>
@@ -7675,12 +7675,12 @@
               </a:spcBef>
             </a:pPr>
             <a:r>
-              <a:rPr sz="1000">
+              <a:rPr sz="950">
                 <a:solidFill>
                   <a:srgbClr val="404040"/>
                 </a:solidFill>
               </a:rPr>
-              <a:t>1. Re-probe each Static study using "At Node number" or the exact same XYZ coordinate (e.g. -4.5, -36.8, 4.0 mm) so every study reads the SAME location.</a:t>
+              <a:t>This is a standard "h-refinement" convergence study: maximum and minimum element size are halved at each step (2/1 -&gt; 0.5/0.25 -&gt; 0.25/0.125 -&gt; 0.125/0.0625 mm) so mesh density is the only variable changing between studies.</a:t>
             </a:r>
           </a:p>
           <a:p>
@@ -7690,12 +7690,12 @@
               </a:spcBef>
             </a:pPr>
             <a:r>
-              <a:rPr sz="1000">
+              <a:rPr sz="950">
                 <a:solidFill>
                   <a:srgbClr val="404040"/>
                 </a:solidFill>
               </a:rPr>
-              <a:t>2. Get element counts from right-click Mesh &gt; Details for each study.</a:t>
+              <a:t>Halving in a fixed ratio isolates mesh density as the cause of any stress change, rather than an arbitrary refinement amount — this proves the result is mesh-independent, not a coincidence of one mesh setting.</a:t>
             </a:r>
           </a:p>
           <a:p>
@@ -7705,12 +7705,12 @@
               </a:spcBef>
             </a:pPr>
             <a:r>
-              <a:rPr sz="1000">
+              <a:rPr sz="950">
                 <a:solidFill>
                   <a:srgbClr val="404040"/>
                 </a:solidFill>
               </a:rPr>
-              <a:t>3. Calculate % Change = |Stress(n) - Stress(n-1)| / Stress(n) x 100%. Stop once this is &lt;= 2%.</a:t>
+              <a:t>Re-probe each Static study at the exact SAME node/location (use "At Node number" or the same XYZ coordinate) — comparing different locations invalidates the convergence ratio.</a:t>
             </a:r>
           </a:p>
           <a:p>
@@ -7720,12 +7720,12 @@
               </a:spcBef>
             </a:pPr>
             <a:r>
-              <a:rPr sz="1000">
+              <a:rPr sz="950">
                 <a:solidFill>
                   <a:srgbClr val="404040"/>
                 </a:solidFill>
               </a:rPr>
-              <a:t>4. Once converged, this table feeds directly into the convergence graph on the next slide.</a:t>
+              <a:t>Calculate % Change = |Stress(n) - Stress(n-1)| / Stress(n) x 100%. Once this is &lt;= 2%, the mesh is fine enough that further refinement will not meaningfully change the result — convergence is achieved.</a:t>
             </a:r>
           </a:p>
         </p:txBody>
@@ -13688,7 +13688,7 @@
         <p:spPr>
           <a:xfrm>
             <a:off x="411480" y="1737360"/>
-            <a:ext cx="5349240" cy="1828800"/>
+            <a:ext cx="5349240" cy="3017520"/>
           </a:xfrm>
           <a:prstGeom prst="rect">
             <a:avLst/>
@@ -13704,6 +13704,121 @@
             <a:pPr>
               <a:spcBef>
                 <a:spcPts val="600"/>
+              </a:spcBef>
+            </a:pPr>
+            <a:r>
+              <a:rPr b="1" sz="1100">
+                <a:solidFill>
+                  <a:srgbClr val="1F3564"/>
+                </a:solidFill>
+              </a:rPr>
+              <a:t>Mesh type: </a:t>
+            </a:r>
+            <a:r>
+              <a:rPr sz="1100">
+                <a:solidFill>
+                  <a:srgbClr val="378644"/>
+                </a:solidFill>
+              </a:rPr>
+              <a:t>Blended curvature-based mesh</a:t>
+            </a:r>
+          </a:p>
+          <a:p>
+            <a:pPr>
+              <a:spcBef>
+                <a:spcPts val="600"/>
+              </a:spcBef>
+            </a:pPr>
+            <a:r>
+              <a:rPr b="1" sz="1100">
+                <a:solidFill>
+                  <a:srgbClr val="1F3564"/>
+                </a:solidFill>
+              </a:rPr>
+              <a:t>Max element size: </a:t>
+            </a:r>
+            <a:r>
+              <a:rPr sz="1100">
+                <a:solidFill>
+                  <a:srgbClr val="378644"/>
+                </a:solidFill>
+              </a:rPr>
+              <a:t>2.00 mm</a:t>
+            </a:r>
+          </a:p>
+          <a:p>
+            <a:pPr>
+              <a:spcBef>
+                <a:spcPts val="600"/>
+              </a:spcBef>
+            </a:pPr>
+            <a:r>
+              <a:rPr b="1" sz="1100">
+                <a:solidFill>
+                  <a:srgbClr val="1F3564"/>
+                </a:solidFill>
+              </a:rPr>
+              <a:t>Min element size: </a:t>
+            </a:r>
+            <a:r>
+              <a:rPr sz="1100">
+                <a:solidFill>
+                  <a:srgbClr val="378644"/>
+                </a:solidFill>
+              </a:rPr>
+              <a:t>1.00 mm</a:t>
+            </a:r>
+          </a:p>
+          <a:p>
+            <a:pPr>
+              <a:spcBef>
+                <a:spcPts val="600"/>
+              </a:spcBef>
+            </a:pPr>
+            <a:r>
+              <a:rPr b="1" sz="1100">
+                <a:solidFill>
+                  <a:srgbClr val="1F3564"/>
+                </a:solidFill>
+              </a:rPr>
+              <a:t>Mesh quality (Jacobian points): </a:t>
+            </a:r>
+            <a:r>
+              <a:rPr sz="1100">
+                <a:solidFill>
+                  <a:srgbClr val="378644"/>
+                </a:solidFill>
+              </a:rPr>
+              <a:t>8</a:t>
+            </a:r>
+          </a:p>
+          <a:p>
+            <a:pPr>
+              <a:spcBef>
+                <a:spcPts val="600"/>
+              </a:spcBef>
+            </a:pPr>
+            <a:r>
+              <a:rPr b="1" sz="1100">
+                <a:solidFill>
+                  <a:srgbClr val="1F3564"/>
+                </a:solidFill>
+              </a:rPr>
+              <a:t>Element size growth ratio: </a:t>
+            </a:r>
+            <a:r>
+              <a:rPr sz="1100">
+                <a:solidFill>
+                  <a:srgbClr val="378644"/>
+                </a:solidFill>
+              </a:rPr>
+              <a:t>1.4</a:t>
+            </a:r>
+          </a:p>
+          <a:p>
+            <a:pPr>
+              <a:spcBef>
+                <a:spcPts val="1000"/>
               </a:spcBef>
             </a:pPr>
             <a:r>
@@ -14442,7 +14557,7 @@
         <p:spPr>
           <a:xfrm>
             <a:off x="411480" y="1737360"/>
-            <a:ext cx="5349240" cy="1828800"/>
+            <a:ext cx="5349240" cy="3017520"/>
           </a:xfrm>
           <a:prstGeom prst="rect">
             <a:avLst/>
@@ -14457,7 +14572,7 @@
           <a:p>
             <a:pPr>
               <a:spcBef>
-                <a:spcPts val="600"/>
+                <a:spcPts val="1000"/>
               </a:spcBef>
             </a:pPr>
             <a:r>

</xml_diff>